<commit_message>
Refine poster result table layout
</commit_message>
<xml_diff>
--- a/poster/poster_final.pptx
+++ b/poster/poster_final.pptx
@@ -6967,7 +6967,7 @@
                 </a:solidFill>
                 <a:latin typeface="Arial"/>
               </a:rPr>
-              <a:t>Selected result</a:t>
+              <a:t>Within-task evidence</a:t>
             </a:r>
           </a:p>
         </p:txBody>
@@ -7087,9 +7087,9 @@
               </a:spcAft>
             </a:pPr>
             <a:r>
-              <a:rPr sz="1400" b="0">
-                <a:solidFill>
-                  <a:srgbClr val="27343C"/>
+              <a:rPr sz="1400" b="1">
+                <a:solidFill>
+                  <a:srgbClr val="17324D"/>
                 </a:solidFill>
                 <a:latin typeface="Arial"/>
               </a:rPr>
@@ -7258,7 +7258,7 @@
             <a:r>
               <a:rPr sz="1400" b="1">
                 <a:solidFill>
-                  <a:srgbClr val="27343C"/>
+                  <a:srgbClr val="17324D"/>
                 </a:solidFill>
                 <a:latin typeface="Arial"/>
               </a:rPr>
@@ -7277,7 +7277,7 @@
             <a:r>
               <a:rPr sz="1400" b="1">
                 <a:solidFill>
-                  <a:srgbClr val="27343C"/>
+                  <a:srgbClr val="17324D"/>
                 </a:solidFill>
                 <a:latin typeface="Arial"/>
               </a:rPr>
@@ -7444,9 +7444,9 @@
               </a:spcAft>
             </a:pPr>
             <a:r>
-              <a:rPr sz="1400" b="0">
-                <a:solidFill>
-                  <a:srgbClr val="27343C"/>
+              <a:rPr sz="1400" b="1">
+                <a:solidFill>
+                  <a:srgbClr val="17324D"/>
                 </a:solidFill>
                 <a:latin typeface="Arial"/>
               </a:rPr>
@@ -7463,9 +7463,9 @@
               </a:spcAft>
             </a:pPr>
             <a:r>
-              <a:rPr sz="1400" b="0">
-                <a:solidFill>
-                  <a:srgbClr val="27343C"/>
+              <a:rPr sz="1400" b="1">
+                <a:solidFill>
+                  <a:srgbClr val="17324D"/>
                 </a:solidFill>
                 <a:latin typeface="Arial"/>
               </a:rPr>
@@ -8140,7 +8140,7 @@
         <p:spPr>
           <a:xfrm>
             <a:off x="9820656" y="23353776"/>
-            <a:ext cx="5184648" cy="283464"/>
+            <a:ext cx="2944368" cy="283464"/>
           </a:xfrm>
           <a:prstGeom prst="rect">
             <a:avLst/>
@@ -8181,8 +8181,8 @@
         </p:nvSpPr>
         <p:spPr>
           <a:xfrm>
-            <a:off x="15169896" y="23353776"/>
-            <a:ext cx="2350008" cy="283464"/>
+            <a:off x="13848588" y="23353776"/>
+            <a:ext cx="2670048" cy="283464"/>
           </a:xfrm>
           <a:prstGeom prst="rect">
             <a:avLst/>
@@ -8223,8 +8223,8 @@
         </p:nvSpPr>
         <p:spPr>
           <a:xfrm>
-            <a:off x="17684496" y="23353776"/>
-            <a:ext cx="2999232" cy="283464"/>
+            <a:off x="17602200" y="23353776"/>
+            <a:ext cx="3081527" cy="283464"/>
           </a:xfrm>
           <a:prstGeom prst="rect">
             <a:avLst/>
@@ -8266,7 +8266,7 @@
         <p:spPr>
           <a:xfrm>
             <a:off x="9820656" y="23719536"/>
-            <a:ext cx="5184648" cy="310896"/>
+            <a:ext cx="2944368" cy="310896"/>
           </a:xfrm>
           <a:prstGeom prst="rect">
             <a:avLst/>
@@ -8307,8 +8307,8 @@
         </p:nvSpPr>
         <p:spPr>
           <a:xfrm>
-            <a:off x="15169896" y="23719536"/>
-            <a:ext cx="2350008" cy="310896"/>
+            <a:off x="13848588" y="23719536"/>
+            <a:ext cx="2670048" cy="310896"/>
           </a:xfrm>
           <a:prstGeom prst="rect">
             <a:avLst/>
@@ -8349,8 +8349,8 @@
         </p:nvSpPr>
         <p:spPr>
           <a:xfrm>
-            <a:off x="17684496" y="23719536"/>
-            <a:ext cx="2999232" cy="310896"/>
+            <a:off x="17602200" y="23719536"/>
+            <a:ext cx="3081527" cy="310896"/>
           </a:xfrm>
           <a:prstGeom prst="rect">
             <a:avLst/>
@@ -8437,7 +8437,7 @@
         <p:spPr>
           <a:xfrm>
             <a:off x="9820656" y="24076152"/>
-            <a:ext cx="5184648" cy="310896"/>
+            <a:ext cx="2944368" cy="310896"/>
           </a:xfrm>
           <a:prstGeom prst="rect">
             <a:avLst/>
@@ -8478,8 +8478,8 @@
         </p:nvSpPr>
         <p:spPr>
           <a:xfrm>
-            <a:off x="15169896" y="24076152"/>
-            <a:ext cx="2350008" cy="310896"/>
+            <a:off x="13848588" y="24076152"/>
+            <a:ext cx="2670048" cy="310896"/>
           </a:xfrm>
           <a:prstGeom prst="rect">
             <a:avLst/>
@@ -8520,8 +8520,8 @@
         </p:nvSpPr>
         <p:spPr>
           <a:xfrm>
-            <a:off x="17684496" y="24076152"/>
-            <a:ext cx="2999232" cy="310896"/>
+            <a:off x="17602200" y="24076152"/>
+            <a:ext cx="3081527" cy="310896"/>
           </a:xfrm>
           <a:prstGeom prst="rect">
             <a:avLst/>
@@ -8606,7 +8606,7 @@
         <p:spPr>
           <a:xfrm>
             <a:off x="9820656" y="24432768"/>
-            <a:ext cx="5184648" cy="310896"/>
+            <a:ext cx="2944368" cy="310896"/>
           </a:xfrm>
           <a:prstGeom prst="rect">
             <a:avLst/>
@@ -8647,8 +8647,8 @@
         </p:nvSpPr>
         <p:spPr>
           <a:xfrm>
-            <a:off x="15169896" y="24432768"/>
-            <a:ext cx="2350008" cy="310896"/>
+            <a:off x="13848588" y="24432768"/>
+            <a:ext cx="2670048" cy="310896"/>
           </a:xfrm>
           <a:prstGeom prst="rect">
             <a:avLst/>
@@ -8689,8 +8689,8 @@
         </p:nvSpPr>
         <p:spPr>
           <a:xfrm>
-            <a:off x="17684496" y="24432768"/>
-            <a:ext cx="2999232" cy="310896"/>
+            <a:off x="17602200" y="24432768"/>
+            <a:ext cx="3081527" cy="310896"/>
           </a:xfrm>
           <a:prstGeom prst="rect">
             <a:avLst/>
@@ -8775,7 +8775,7 @@
         <p:spPr>
           <a:xfrm>
             <a:off x="9820656" y="24789384"/>
-            <a:ext cx="5184648" cy="310896"/>
+            <a:ext cx="2944368" cy="310896"/>
           </a:xfrm>
           <a:prstGeom prst="rect">
             <a:avLst/>
@@ -8816,8 +8816,8 @@
         </p:nvSpPr>
         <p:spPr>
           <a:xfrm>
-            <a:off x="15169896" y="24789384"/>
-            <a:ext cx="2350008" cy="310896"/>
+            <a:off x="13848588" y="24789384"/>
+            <a:ext cx="2670048" cy="310896"/>
           </a:xfrm>
           <a:prstGeom prst="rect">
             <a:avLst/>
@@ -8858,8 +8858,8 @@
         </p:nvSpPr>
         <p:spPr>
           <a:xfrm>
-            <a:off x="17684496" y="24789384"/>
-            <a:ext cx="2999232" cy="310896"/>
+            <a:off x="17602200" y="24789384"/>
+            <a:ext cx="3081527" cy="310896"/>
           </a:xfrm>
           <a:prstGeom prst="rect">
             <a:avLst/>
@@ -8946,7 +8946,7 @@
         <p:spPr>
           <a:xfrm>
             <a:off x="9820656" y="25146000"/>
-            <a:ext cx="5184648" cy="310896"/>
+            <a:ext cx="2944368" cy="310896"/>
           </a:xfrm>
           <a:prstGeom prst="rect">
             <a:avLst/>
@@ -8987,8 +8987,8 @@
         </p:nvSpPr>
         <p:spPr>
           <a:xfrm>
-            <a:off x="15169896" y="25146000"/>
-            <a:ext cx="2350008" cy="310896"/>
+            <a:off x="13848588" y="25146000"/>
+            <a:ext cx="2670048" cy="310896"/>
           </a:xfrm>
           <a:prstGeom prst="rect">
             <a:avLst/>
@@ -9029,8 +9029,8 @@
         </p:nvSpPr>
         <p:spPr>
           <a:xfrm>
-            <a:off x="17684496" y="25146000"/>
-            <a:ext cx="2999232" cy="310896"/>
+            <a:off x="17602200" y="25146000"/>
+            <a:ext cx="3081527" cy="310896"/>
           </a:xfrm>
           <a:prstGeom prst="rect">
             <a:avLst/>

</xml_diff>